<commit_message>
Pipeline figure v1.1: attempt-first block in Stage II, Stage III = SFT + pref + averaging, masked-pref caption
Co-Authored-By: Claude Fable 5 <noreply@anthropic.com>
</commit_message>
<xml_diff>
--- a/paper/figs/fig1_pipeline_v14.pptx
+++ b/paper/figs/fig1_pipeline_v14.pptx
@@ -3222,6 +3222,7 @@
             <a:avLst/>
           </a:prstGeom>
           <a:noFill/>
+          <a:effectLst/>
         </p:spPr>
         <p:txBody>
           <a:bodyPr wrap="square" lIns="0" rIns="0" tIns="0" bIns="0">
@@ -3449,6 +3450,7 @@
             <a:avLst/>
           </a:prstGeom>
           <a:noFill/>
+          <a:effectLst/>
         </p:spPr>
         <p:txBody>
           <a:bodyPr wrap="square" lIns="0" rIns="0" tIns="0" bIns="0">
@@ -3507,6 +3509,7 @@
             <a:avLst/>
           </a:prstGeom>
           <a:noFill/>
+          <a:effectLst/>
         </p:spPr>
         <p:txBody>
           <a:bodyPr wrap="square" lIns="0" rIns="0" tIns="0" bIns="0">
@@ -3728,6 +3731,7 @@
             <a:avLst/>
           </a:prstGeom>
           <a:noFill/>
+          <a:effectLst/>
         </p:spPr>
         <p:txBody>
           <a:bodyPr wrap="square" lIns="0" rIns="0" tIns="0" bIns="0">
@@ -4024,6 +4028,7 @@
             <a:avLst/>
           </a:prstGeom>
           <a:noFill/>
+          <a:effectLst/>
         </p:spPr>
         <p:txBody>
           <a:bodyPr wrap="square" lIns="0" rIns="0" tIns="0" bIns="0">
@@ -4102,6 +4107,7 @@
             <a:avLst/>
           </a:prstGeom>
           <a:noFill/>
+          <a:effectLst/>
         </p:spPr>
         <p:txBody>
           <a:bodyPr wrap="square" lIns="0" rIns="0" tIns="0" bIns="0">
@@ -4194,6 +4200,7 @@
             <a:avLst/>
           </a:prstGeom>
           <a:noFill/>
+          <a:effectLst/>
         </p:spPr>
         <p:txBody>
           <a:bodyPr wrap="square" lIns="0" rIns="0" tIns="0" bIns="0">
@@ -4263,6 +4270,7 @@
             <a:avLst/>
           </a:prstGeom>
           <a:noFill/>
+          <a:effectLst/>
         </p:spPr>
         <p:txBody>
           <a:bodyPr wrap="square" lIns="0" rIns="0" tIns="0" bIns="0">
@@ -4332,6 +4340,7 @@
             <a:avLst/>
           </a:prstGeom>
           <a:noFill/>
+          <a:effectLst/>
         </p:spPr>
         <p:txBody>
           <a:bodyPr wrap="square" lIns="0" rIns="0" tIns="0" bIns="0">
@@ -4401,6 +4410,7 @@
             <a:avLst/>
           </a:prstGeom>
           <a:noFill/>
+          <a:effectLst/>
         </p:spPr>
         <p:txBody>
           <a:bodyPr wrap="square" lIns="0" rIns="0" tIns="0" bIns="0">
@@ -4470,6 +4480,7 @@
             <a:avLst/>
           </a:prstGeom>
           <a:noFill/>
+          <a:effectLst/>
         </p:spPr>
         <p:txBody>
           <a:bodyPr wrap="square" lIns="0" rIns="0" tIns="0" bIns="0">
@@ -4505,6 +4516,7 @@
             <a:avLst/>
           </a:prstGeom>
           <a:noFill/>
+          <a:effectLst/>
         </p:spPr>
         <p:txBody>
           <a:bodyPr wrap="square" lIns="0" rIns="0" tIns="0" bIns="0">
@@ -4801,6 +4813,7 @@
             <a:avLst/>
           </a:prstGeom>
           <a:noFill/>
+          <a:effectLst/>
         </p:spPr>
         <p:txBody>
           <a:bodyPr wrap="square" lIns="0" rIns="0" tIns="0" bIns="0">
@@ -5009,6 +5022,7 @@
             <a:avLst/>
           </a:prstGeom>
           <a:noFill/>
+          <a:effectLst/>
         </p:spPr>
         <p:txBody>
           <a:bodyPr wrap="square" lIns="0" rIns="0" tIns="0" bIns="0">
@@ -5162,6 +5176,7 @@
             <a:avLst/>
           </a:prstGeom>
           <a:noFill/>
+          <a:effectLst/>
         </p:spPr>
         <p:txBody>
           <a:bodyPr wrap="square" lIns="0" rIns="0" tIns="0" bIns="0">
@@ -5542,6 +5557,7 @@
             <a:avLst/>
           </a:prstGeom>
           <a:noFill/>
+          <a:effectLst/>
         </p:spPr>
         <p:txBody>
           <a:bodyPr wrap="square" lIns="0" rIns="0" tIns="0" bIns="0">
@@ -5718,6 +5734,7 @@
             <a:avLst/>
           </a:prstGeom>
           <a:noFill/>
+          <a:effectLst/>
         </p:spPr>
         <p:txBody>
           <a:bodyPr wrap="square" lIns="0" rIns="0" tIns="0" bIns="0">
@@ -5753,6 +5770,7 @@
             <a:avLst/>
           </a:prstGeom>
           <a:noFill/>
+          <a:effectLst/>
         </p:spPr>
         <p:txBody>
           <a:bodyPr wrap="square" lIns="0" rIns="0" tIns="0" bIns="0">
@@ -5839,6 +5857,7 @@
             <a:avLst/>
           </a:prstGeom>
           <a:noFill/>
+          <a:effectLst/>
         </p:spPr>
         <p:txBody>
           <a:bodyPr wrap="square" lIns="0" rIns="0" tIns="0" bIns="0">
@@ -6060,6 +6079,7 @@
             <a:avLst/>
           </a:prstGeom>
           <a:noFill/>
+          <a:effectLst/>
         </p:spPr>
         <p:txBody>
           <a:bodyPr wrap="square" lIns="0" rIns="0" tIns="0" bIns="0">
@@ -6223,6 +6243,7 @@
             <a:avLst/>
           </a:prstGeom>
           <a:noFill/>
+          <a:effectLst/>
         </p:spPr>
         <p:txBody>
           <a:bodyPr wrap="square" lIns="0" rIns="0" tIns="0" bIns="0">
@@ -6405,6 +6426,7 @@
             <a:avLst/>
           </a:prstGeom>
           <a:noFill/>
+          <a:effectLst/>
         </p:spPr>
         <p:txBody>
           <a:bodyPr wrap="square" lIns="0" rIns="0" tIns="0" bIns="0">
@@ -6581,6 +6603,7 @@
             <a:avLst/>
           </a:prstGeom>
           <a:noFill/>
+          <a:effectLst/>
         </p:spPr>
         <p:txBody>
           <a:bodyPr wrap="square" lIns="0" rIns="0" tIns="0" bIns="0">
@@ -6757,6 +6780,7 @@
             <a:avLst/>
           </a:prstGeom>
           <a:noFill/>
+          <a:effectLst/>
         </p:spPr>
         <p:txBody>
           <a:bodyPr wrap="square" lIns="0" rIns="0" tIns="0" bIns="0">
@@ -6902,6 +6926,7 @@
             <a:avLst/>
           </a:prstGeom>
           <a:noFill/>
+          <a:effectLst/>
         </p:spPr>
         <p:txBody>
           <a:bodyPr wrap="square" lIns="0" rIns="0" tIns="0" bIns="0">
@@ -6937,6 +6962,7 @@
             <a:avLst/>
           </a:prstGeom>
           <a:noFill/>
+          <a:effectLst/>
         </p:spPr>
         <p:txBody>
           <a:bodyPr wrap="square" lIns="0" rIns="0" tIns="0" bIns="0">
@@ -7054,6 +7080,7 @@
             <a:avLst/>
           </a:prstGeom>
           <a:noFill/>
+          <a:effectLst/>
         </p:spPr>
         <p:txBody>
           <a:bodyPr wrap="square" lIns="0" rIns="0" tIns="0" bIns="0">
@@ -7517,13 +7544,14 @@
         </p:nvSpPr>
         <p:spPr>
           <a:xfrm>
-            <a:off x="9464040" y="3401568"/>
+            <a:off x="9464040" y="3273552"/>
             <a:ext cx="2651760" cy="292608"/>
           </a:xfrm>
           <a:prstGeom prst="rect">
             <a:avLst/>
           </a:prstGeom>
           <a:noFill/>
+          <a:effectLst/>
         </p:spPr>
         <p:txBody>
           <a:bodyPr wrap="square" lIns="0" rIns="0" tIns="0" bIns="0">
@@ -7533,13 +7561,13 @@
           <a:p>
             <a:pPr algn="ctr"/>
             <a:r>
-              <a:rPr sz="1350" b="1" i="1">
+              <a:rPr sz="1300" b="1" i="1">
                 <a:solidFill>
                   <a:srgbClr val="111111"/>
                 </a:solidFill>
                 <a:latin typeface="Times New Roman"/>
               </a:rPr>
-              <a:t>deficit read from student's</a:t>
+              <a:t>student attempts shortlist first:</a:t>
             </a:r>
           </a:p>
         </p:txBody>
@@ -7552,13 +7580,14 @@
         </p:nvSpPr>
         <p:spPr>
           <a:xfrm>
-            <a:off x="9464040" y="3602736"/>
+            <a:off x="9464040" y="3465576"/>
             <a:ext cx="2651760" cy="292608"/>
           </a:xfrm>
           <a:prstGeom prst="rect">
             <a:avLst/>
           </a:prstGeom>
           <a:noFill/>
+          <a:effectLst/>
         </p:spPr>
         <p:txBody>
           <a:bodyPr wrap="square" lIns="0" rIns="0" tIns="0" bIns="0">
@@ -7568,13 +7597,13 @@
           <a:p>
             <a:pPr algn="ctr"/>
             <a:r>
-              <a:rPr sz="1350" b="1" i="1">
+              <a:rPr sz="1300" b="1" i="1">
                 <a:solidFill>
                   <a:srgbClr val="111111"/>
                 </a:solidFill>
                 <a:latin typeface="Times New Roman"/>
               </a:rPr>
-              <a:t>loss curves → next round;</a:t>
+              <a:t>self-solved → keep, free;</a:t>
             </a:r>
           </a:p>
         </p:txBody>
@@ -7587,13 +7616,14 @@
         </p:nvSpPr>
         <p:spPr>
           <a:xfrm>
-            <a:off x="9464040" y="3803904"/>
+            <a:off x="9464040" y="3657600"/>
             <a:ext cx="2651760" cy="292608"/>
           </a:xfrm>
           <a:prstGeom prst="rect">
             <a:avLst/>
           </a:prstGeom>
           <a:noFill/>
+          <a:effectLst/>
         </p:spPr>
         <p:txBody>
           <a:bodyPr wrap="square" lIns="0" rIns="0" tIns="0" bIns="0">
@@ -7603,20 +7633,56 @@
           <a:p>
             <a:pPr algn="ctr"/>
             <a:r>
-              <a:rPr sz="1350" b="1" i="1">
+              <a:rPr sz="1300" b="1" i="1">
                 <a:solidFill>
                   <a:srgbClr val="111111"/>
                 </a:solidFill>
                 <a:latin typeface="Times New Roman"/>
               </a:rPr>
-              <a:t>starved skills → generate</a:t>
-            </a:r>
-          </a:p>
-        </p:txBody>
-      </p:sp>
-      <p:sp>
-        <p:nvSpPr>
-          <p:cNvPr id="150" name="Oval 149"/>
+              <a:t>failures → buy demo / correction;</a:t>
+            </a:r>
+          </a:p>
+        </p:txBody>
+      </p:sp>
+      <p:sp>
+        <p:nvSpPr>
+          <p:cNvPr id="150" name="TextBox 149"/>
+          <p:cNvSpPr txBox="1"/>
+          <p:nvPr/>
+        </p:nvSpPr>
+        <p:spPr>
+          <a:xfrm>
+            <a:off x="9464040" y="3849624"/>
+            <a:ext cx="2651760" cy="292608"/>
+          </a:xfrm>
+          <a:prstGeom prst="rect">
+            <a:avLst/>
+          </a:prstGeom>
+          <a:noFill/>
+          <a:effectLst/>
+        </p:spPr>
+        <p:txBody>
+          <a:bodyPr wrap="square" lIns="0" rIns="0" tIns="0" bIns="0">
+            <a:spAutoFit/>
+          </a:bodyPr>
+          <a:lstStyle/>
+          <a:p>
+            <a:pPr algn="ctr"/>
+            <a:r>
+              <a:rPr sz="1300" b="1" i="1">
+                <a:solidFill>
+                  <a:srgbClr val="111111"/>
+                </a:solidFill>
+                <a:latin typeface="Times New Roman"/>
+              </a:rPr>
+              <a:t>deficit read → next round</a:t>
+            </a:r>
+          </a:p>
+        </p:txBody>
+      </p:sp>
+      <p:sp>
+        <p:nvSpPr>
+          <p:cNvPr id="151" name="Oval 150"/>
           <p:cNvSpPr/>
           <p:nvPr/>
         </p:nvSpPr>
@@ -7655,19 +7721,20 @@
       </p:sp>
       <p:sp>
         <p:nvSpPr>
-          <p:cNvPr id="151" name="TextBox 150"/>
+          <p:cNvPr id="152" name="TextBox 151"/>
           <p:cNvSpPr txBox="1"/>
           <p:nvPr/>
         </p:nvSpPr>
         <p:spPr>
           <a:xfrm>
             <a:off x="6748272" y="4242816"/>
-            <a:ext cx="2834640" cy="292608"/>
+            <a:ext cx="3108960" cy="292608"/>
           </a:xfrm>
           <a:prstGeom prst="rect">
             <a:avLst/>
           </a:prstGeom>
           <a:noFill/>
+          <a:effectLst/>
         </p:spPr>
         <p:txBody>
           <a:bodyPr wrap="square" lIns="0" rIns="0" tIns="0" bIns="0">
@@ -7677,20 +7744,20 @@
           <a:p>
             <a:pPr algn="l"/>
             <a:r>
-              <a:rPr sz="1700" b="1" i="1">
+              <a:rPr sz="1450" b="1" i="1">
                 <a:solidFill>
                   <a:srgbClr val="111111"/>
                 </a:solidFill>
                 <a:latin typeface="Times New Roman"/>
               </a:rPr>
-              <a:t>Stage III — mixed-source SFT</a:t>
-            </a:r>
-          </a:p>
-        </p:txBody>
-      </p:sp>
-      <p:sp>
-        <p:nvSpPr>
-          <p:cNvPr id="152" name="Oval 151"/>
+              <a:t>Stage III — SFT + pref + averaging</a:t>
+            </a:r>
+          </a:p>
+        </p:txBody>
+      </p:sp>
+      <p:sp>
+        <p:nvSpPr>
+          <p:cNvPr id="153" name="Oval 152"/>
           <p:cNvSpPr/>
           <p:nvPr/>
         </p:nvSpPr>
@@ -7729,7 +7796,7 @@
       </p:sp>
       <p:sp>
         <p:nvSpPr>
-          <p:cNvPr id="153" name="TextBox 152"/>
+          <p:cNvPr id="154" name="TextBox 153"/>
           <p:cNvSpPr txBox="1"/>
           <p:nvPr/>
         </p:nvSpPr>
@@ -7742,6 +7809,7 @@
             <a:avLst/>
           </a:prstGeom>
           <a:noFill/>
+          <a:effectLst/>
         </p:spPr>
         <p:txBody>
           <a:bodyPr wrap="square" lIns="0" rIns="0" tIns="0" bIns="0">
@@ -7764,7 +7832,7 @@
       </p:sp>
       <p:sp>
         <p:nvSpPr>
-          <p:cNvPr id="154" name="Rounded Rectangle 153"/>
+          <p:cNvPr id="155" name="Rounded Rectangle 154"/>
           <p:cNvSpPr/>
           <p:nvPr/>
         </p:nvSpPr>
@@ -7798,7 +7866,7 @@
       </p:sp>
       <p:sp>
         <p:nvSpPr>
-          <p:cNvPr id="155" name="Rectangle 154"/>
+          <p:cNvPr id="156" name="Rectangle 155"/>
           <p:cNvSpPr/>
           <p:nvPr/>
         </p:nvSpPr>
@@ -7828,7 +7896,7 @@
       </p:sp>
       <p:sp>
         <p:nvSpPr>
-          <p:cNvPr id="156" name="Rectangle 155"/>
+          <p:cNvPr id="157" name="Rectangle 156"/>
           <p:cNvSpPr/>
           <p:nvPr/>
         </p:nvSpPr>
@@ -7860,7 +7928,7 @@
       </p:sp>
       <p:sp>
         <p:nvSpPr>
-          <p:cNvPr id="157" name="Rounded Rectangle 156"/>
+          <p:cNvPr id="158" name="Rounded Rectangle 157"/>
           <p:cNvSpPr/>
           <p:nvPr/>
         </p:nvSpPr>
@@ -7894,7 +7962,7 @@
       </p:sp>
       <p:sp>
         <p:nvSpPr>
-          <p:cNvPr id="158" name="Rectangle 157"/>
+          <p:cNvPr id="159" name="Rectangle 158"/>
           <p:cNvSpPr/>
           <p:nvPr/>
         </p:nvSpPr>
@@ -7924,7 +7992,7 @@
       </p:sp>
       <p:sp>
         <p:nvSpPr>
-          <p:cNvPr id="159" name="Rectangle 158"/>
+          <p:cNvPr id="160" name="Rectangle 159"/>
           <p:cNvSpPr/>
           <p:nvPr/>
         </p:nvSpPr>
@@ -7956,7 +8024,7 @@
       </p:sp>
       <p:sp>
         <p:nvSpPr>
-          <p:cNvPr id="160" name="Rounded Rectangle 159"/>
+          <p:cNvPr id="161" name="Rounded Rectangle 160"/>
           <p:cNvSpPr/>
           <p:nvPr/>
         </p:nvSpPr>
@@ -7990,7 +8058,7 @@
       </p:sp>
       <p:sp>
         <p:nvSpPr>
-          <p:cNvPr id="161" name="Rectangle 160"/>
+          <p:cNvPr id="162" name="Rectangle 161"/>
           <p:cNvSpPr/>
           <p:nvPr/>
         </p:nvSpPr>
@@ -8020,7 +8088,7 @@
       </p:sp>
       <p:sp>
         <p:nvSpPr>
-          <p:cNvPr id="162" name="Rectangle 161"/>
+          <p:cNvPr id="163" name="Rectangle 162"/>
           <p:cNvSpPr/>
           <p:nvPr/>
         </p:nvSpPr>
@@ -8052,7 +8120,7 @@
       </p:sp>
       <p:sp>
         <p:nvSpPr>
-          <p:cNvPr id="163" name="TextBox 162"/>
+          <p:cNvPr id="164" name="TextBox 163"/>
           <p:cNvSpPr txBox="1"/>
           <p:nvPr/>
         </p:nvSpPr>
@@ -8065,6 +8133,7 @@
             <a:avLst/>
           </a:prstGeom>
           <a:noFill/>
+          <a:effectLst/>
         </p:spPr>
         <p:txBody>
           <a:bodyPr wrap="square" lIns="0" rIns="0" tIns="0" bIns="0">
@@ -8074,20 +8143,20 @@
           <a:p>
             <a:pPr algn="ctr"/>
             <a:r>
-              <a:rPr sz="1200" b="1" i="1">
+              <a:rPr sz="1150" b="1" i="1">
                 <a:solidFill>
                   <a:srgbClr val="111111"/>
                 </a:solidFill>
                 <a:latin typeface="Times New Roman"/>
               </a:rPr>
-              <a:t>teacher demos ∪ self-verified</a:t>
+              <a:t>demos ∪ corrections ∪ self-solved</a:t>
             </a:r>
           </a:p>
         </p:txBody>
       </p:sp>
       <p:cxnSp>
         <p:nvCxnSpPr>
-          <p:cNvPr id="164" name="Connector 163"/>
+          <p:cNvPr id="165" name="Connector 164"/>
           <p:cNvCxnSpPr/>
           <p:nvPr/>
         </p:nvCxnSpPr>
@@ -8110,7 +8179,7 @@
       </p:cxnSp>
       <p:sp>
         <p:nvSpPr>
-          <p:cNvPr id="165" name="Rounded Rectangle 164"/>
+          <p:cNvPr id="166" name="Rounded Rectangle 165"/>
           <p:cNvSpPr/>
           <p:nvPr/>
         </p:nvSpPr>
@@ -8144,7 +8213,7 @@
       </p:sp>
       <p:sp>
         <p:nvSpPr>
-          <p:cNvPr id="166" name="Rectangle 165"/>
+          <p:cNvPr id="167" name="Rectangle 166"/>
           <p:cNvSpPr/>
           <p:nvPr/>
         </p:nvSpPr>
@@ -8174,7 +8243,7 @@
       </p:sp>
       <p:sp>
         <p:nvSpPr>
-          <p:cNvPr id="167" name="Oval 166"/>
+          <p:cNvPr id="168" name="Oval 167"/>
           <p:cNvSpPr/>
           <p:nvPr/>
         </p:nvSpPr>
@@ -8204,7 +8273,7 @@
       </p:sp>
       <p:sp>
         <p:nvSpPr>
-          <p:cNvPr id="168" name="Oval 167"/>
+          <p:cNvPr id="169" name="Oval 168"/>
           <p:cNvSpPr/>
           <p:nvPr/>
         </p:nvSpPr>
@@ -8234,7 +8303,7 @@
       </p:sp>
       <p:sp>
         <p:nvSpPr>
-          <p:cNvPr id="169" name="Oval 168"/>
+          <p:cNvPr id="170" name="Oval 169"/>
           <p:cNvSpPr/>
           <p:nvPr/>
         </p:nvSpPr>
@@ -8264,7 +8333,7 @@
       </p:sp>
       <p:sp>
         <p:nvSpPr>
-          <p:cNvPr id="170" name="Rounded Rectangle 169"/>
+          <p:cNvPr id="171" name="Rounded Rectangle 170"/>
           <p:cNvSpPr/>
           <p:nvPr/>
         </p:nvSpPr>
@@ -8296,7 +8365,7 @@
       </p:sp>
       <p:sp>
         <p:nvSpPr>
-          <p:cNvPr id="171" name="TextBox 170"/>
+          <p:cNvPr id="172" name="TextBox 171"/>
           <p:cNvSpPr txBox="1"/>
           <p:nvPr/>
         </p:nvSpPr>
@@ -8309,6 +8378,7 @@
             <a:avLst/>
           </a:prstGeom>
           <a:noFill/>
+          <a:effectLst/>
         </p:spPr>
         <p:txBody>
           <a:bodyPr wrap="square" lIns="0" rIns="0" tIns="0" bIns="0">
@@ -8331,35 +8401,13 @@
       </p:sp>
       <p:cxnSp>
         <p:nvCxnSpPr>
-          <p:cNvPr id="172" name="Connector 171"/>
-          <p:cNvCxnSpPr/>
-          <p:nvPr/>
-        </p:nvCxnSpPr>
-        <p:spPr>
-          <a:xfrm>
-            <a:off x="6720840" y="6492240"/>
-            <a:ext cx="1417320" cy="0"/>
-          </a:xfrm>
-          <a:prstGeom prst="line">
-            <a:avLst/>
-          </a:prstGeom>
-          <a:ln w="11430">
-            <a:solidFill>
-              <a:srgbClr val="E0E0E0"/>
-            </a:solidFill>
-          </a:ln>
-          <a:effectLst/>
-        </p:spPr>
-      </p:cxnSp>
-      <p:cxnSp>
-        <p:nvCxnSpPr>
           <p:cNvPr id="173" name="Connector 172"/>
           <p:cNvCxnSpPr/>
           <p:nvPr/>
         </p:nvCxnSpPr>
         <p:spPr>
           <a:xfrm>
-            <a:off x="6720840" y="6345936"/>
+            <a:off x="6720840" y="6492240"/>
             <a:ext cx="1417320" cy="0"/>
           </a:xfrm>
           <a:prstGeom prst="line">
@@ -8381,7 +8429,7 @@
         </p:nvCxnSpPr>
         <p:spPr>
           <a:xfrm>
-            <a:off x="6720840" y="6199631"/>
+            <a:off x="6720840" y="6345936"/>
             <a:ext cx="1417320" cy="0"/>
           </a:xfrm>
           <a:prstGeom prst="line">
@@ -8402,16 +8450,16 @@
           <p:nvPr/>
         </p:nvCxnSpPr>
         <p:spPr>
-          <a:xfrm flipV="1">
-            <a:off x="6748272" y="6236208"/>
-            <a:ext cx="292608" cy="192024"/>
+          <a:xfrm>
+            <a:off x="6720840" y="6199631"/>
+            <a:ext cx="1417320" cy="0"/>
           </a:xfrm>
           <a:prstGeom prst="line">
             <a:avLst/>
           </a:prstGeom>
-          <a:ln w="33020">
-            <a:solidFill>
-              <a:srgbClr val="4C72B0"/>
+          <a:ln w="11430">
+            <a:solidFill>
+              <a:srgbClr val="E0E0E0"/>
             </a:solidFill>
           </a:ln>
           <a:effectLst/>
@@ -8425,8 +8473,8 @@
         </p:nvCxnSpPr>
         <p:spPr>
           <a:xfrm flipV="1">
-            <a:off x="7040880" y="6053328"/>
-            <a:ext cx="320040" cy="182880"/>
+            <a:off x="6748272" y="6236208"/>
+            <a:ext cx="292608" cy="192024"/>
           </a:xfrm>
           <a:prstGeom prst="line">
             <a:avLst/>
@@ -8447,8 +8495,8 @@
         </p:nvCxnSpPr>
         <p:spPr>
           <a:xfrm flipV="1">
-            <a:off x="7360920" y="5998464"/>
-            <a:ext cx="274320" cy="54864"/>
+            <a:off x="7040880" y="6053328"/>
+            <a:ext cx="320040" cy="182880"/>
           </a:xfrm>
           <a:prstGeom prst="line">
             <a:avLst/>
@@ -8468,6 +8516,28 @@
           <p:nvPr/>
         </p:nvCxnSpPr>
         <p:spPr>
+          <a:xfrm flipV="1">
+            <a:off x="7360920" y="5998464"/>
+            <a:ext cx="274320" cy="54864"/>
+          </a:xfrm>
+          <a:prstGeom prst="line">
+            <a:avLst/>
+          </a:prstGeom>
+          <a:ln w="33020">
+            <a:solidFill>
+              <a:srgbClr val="4C72B0"/>
+            </a:solidFill>
+          </a:ln>
+          <a:effectLst/>
+        </p:spPr>
+      </p:cxnSp>
+      <p:cxnSp>
+        <p:nvCxnSpPr>
+          <p:cNvPr id="179" name="Connector 178"/>
+          <p:cNvCxnSpPr/>
+          <p:nvPr/>
+        </p:nvCxnSpPr>
+        <p:spPr>
           <a:xfrm>
             <a:off x="7635240" y="5998464"/>
             <a:ext cx="274320" cy="109728"/>
@@ -8485,7 +8555,7 @@
       </p:cxnSp>
       <p:sp>
         <p:nvSpPr>
-          <p:cNvPr id="179" name="Oval 178"/>
+          <p:cNvPr id="180" name="Oval 179"/>
           <p:cNvSpPr/>
           <p:nvPr/>
         </p:nvSpPr>
@@ -8517,19 +8587,20 @@
       </p:sp>
       <p:sp>
         <p:nvSpPr>
-          <p:cNvPr id="180" name="TextBox 179"/>
+          <p:cNvPr id="181" name="TextBox 180"/>
           <p:cNvSpPr txBox="1"/>
           <p:nvPr/>
         </p:nvSpPr>
         <p:spPr>
           <a:xfrm>
-            <a:off x="6400800" y="6510528"/>
-            <a:ext cx="2560320" cy="292608"/>
+            <a:off x="6035040" y="6492240"/>
+            <a:ext cx="3108960" cy="292608"/>
           </a:xfrm>
           <a:prstGeom prst="rect">
             <a:avLst/>
           </a:prstGeom>
           <a:noFill/>
+          <a:effectLst/>
         </p:spPr>
         <p:txBody>
           <a:bodyPr wrap="square" lIns="0" rIns="0" tIns="0" bIns="0">
@@ -8539,20 +8610,20 @@
           <a:p>
             <a:pPr algn="ctr"/>
             <a:r>
-              <a:rPr sz="1100" b="1" i="1">
+              <a:rPr sz="950" b="1" i="1">
                 <a:solidFill>
                   <a:srgbClr val="111111"/>
                 </a:solidFill>
                 <a:latin typeface="Times New Roman"/>
               </a:rPr>
-              <a:t>rollback only past 1-probe margin</a:t>
-            </a:r>
-          </a:p>
-        </p:txBody>
-      </p:sp>
-      <p:sp>
-        <p:nvSpPr>
-          <p:cNvPr id="181" name="Rounded Rectangle 180"/>
+              <a:t>masked pref (attempt, fix) · avg ckpts · 1-probe rollback</a:t>
+            </a:r>
+          </a:p>
+        </p:txBody>
+      </p:sp>
+      <p:sp>
+        <p:nvSpPr>
+          <p:cNvPr id="182" name="Rounded Rectangle 181"/>
           <p:cNvSpPr/>
           <p:nvPr/>
         </p:nvSpPr>
@@ -8586,7 +8657,7 @@
       </p:sp>
       <p:sp>
         <p:nvSpPr>
-          <p:cNvPr id="182" name="Oval 181"/>
+          <p:cNvPr id="183" name="Oval 182"/>
           <p:cNvSpPr/>
           <p:nvPr/>
         </p:nvSpPr>
@@ -8627,7 +8698,7 @@
       </p:sp>
       <p:sp>
         <p:nvSpPr>
-          <p:cNvPr id="183" name="TextBox 182"/>
+          <p:cNvPr id="184" name="TextBox 183"/>
           <p:cNvSpPr txBox="1"/>
           <p:nvPr/>
         </p:nvSpPr>
@@ -8640,6 +8711,7 @@
             <a:avLst/>
           </a:prstGeom>
           <a:noFill/>
+          <a:effectLst/>
         </p:spPr>
         <p:txBody>
           <a:bodyPr wrap="square" lIns="0" rIns="0" tIns="0" bIns="0">
@@ -8674,7 +8746,7 @@
       </p:sp>
       <p:sp>
         <p:nvSpPr>
-          <p:cNvPr id="184" name="TextBox 183"/>
+          <p:cNvPr id="185" name="TextBox 184"/>
           <p:cNvSpPr txBox="1"/>
           <p:nvPr/>
         </p:nvSpPr>
@@ -8687,6 +8759,7 @@
             <a:avLst/>
           </a:prstGeom>
           <a:noFill/>
+          <a:effectLst/>
         </p:spPr>
         <p:txBody>
           <a:bodyPr wrap="square" lIns="0" rIns="0" tIns="0" bIns="0">
@@ -8709,7 +8782,7 @@
       </p:sp>
       <p:sp>
         <p:nvSpPr>
-          <p:cNvPr id="185" name="Diamond 184"/>
+          <p:cNvPr id="186" name="Diamond 185"/>
           <p:cNvSpPr/>
           <p:nvPr/>
         </p:nvSpPr>
@@ -8741,7 +8814,7 @@
       </p:sp>
       <p:sp>
         <p:nvSpPr>
-          <p:cNvPr id="186" name="TextBox 185"/>
+          <p:cNvPr id="187" name="TextBox 186"/>
           <p:cNvSpPr txBox="1"/>
           <p:nvPr/>
         </p:nvSpPr>
@@ -8754,6 +8827,7 @@
             <a:avLst/>
           </a:prstGeom>
           <a:noFill/>
+          <a:effectLst/>
         </p:spPr>
         <p:txBody>
           <a:bodyPr wrap="square" lIns="0" rIns="0" tIns="0" bIns="0">
@@ -8776,7 +8850,7 @@
       </p:sp>
       <p:sp>
         <p:nvSpPr>
-          <p:cNvPr id="187" name="TextBox 186"/>
+          <p:cNvPr id="188" name="TextBox 187"/>
           <p:cNvSpPr txBox="1"/>
           <p:nvPr/>
         </p:nvSpPr>
@@ -8789,6 +8863,7 @@
             <a:avLst/>
           </a:prstGeom>
           <a:noFill/>
+          <a:effectLst/>
         </p:spPr>
         <p:txBody>
           <a:bodyPr wrap="square" lIns="0" rIns="0" tIns="0" bIns="0">
@@ -8811,7 +8886,7 @@
       </p:sp>
       <p:cxnSp>
         <p:nvCxnSpPr>
-          <p:cNvPr id="188" name="Connector 187"/>
+          <p:cNvPr id="189" name="Connector 188"/>
           <p:cNvCxnSpPr/>
           <p:nvPr/>
         </p:nvCxnSpPr>
@@ -9026,13 +9101,42 @@
       </a:lnStyleLst>
       <a:effectStyleLst>
         <a:effectStyle>
-          <a:effectLst/>
+          <a:effectLst>
+            <a:outerShdw blurRad="40000" dist="20000" dir="5400000" rotWithShape="0">
+              <a:srgbClr val="000000">
+                <a:alpha val="38000"/>
+              </a:srgbClr>
+            </a:outerShdw>
+          </a:effectLst>
         </a:effectStyle>
         <a:effectStyle>
-          <a:effectLst/>
+          <a:effectLst>
+            <a:outerShdw blurRad="40000" dist="23000" dir="5400000" rotWithShape="0">
+              <a:srgbClr val="000000">
+                <a:alpha val="35000"/>
+              </a:srgbClr>
+            </a:outerShdw>
+          </a:effectLst>
         </a:effectStyle>
         <a:effectStyle>
-          <a:effectLst/>
+          <a:effectLst>
+            <a:outerShdw blurRad="40000" dist="23000" dir="5400000" rotWithShape="0">
+              <a:srgbClr val="000000">
+                <a:alpha val="35000"/>
+              </a:srgbClr>
+            </a:outerShdw>
+          </a:effectLst>
+          <a:scene3d>
+            <a:camera prst="orthographicFront">
+              <a:rot lat="0" lon="0" rev="0"/>
+            </a:camera>
+            <a:lightRig rig="threePt" dir="t">
+              <a:rot lat="0" lon="0" rev="1200000"/>
+            </a:lightRig>
+          </a:scene3d>
+          <a:sp3d>
+            <a:bevelT w="63500" h="25400"/>
+          </a:sp3d>
         </a:effectStyle>
       </a:effectStyleLst>
       <a:bgFillStyleLst>

</xml_diff>